<commit_message>
Bring the join code back; capitalize names and MBTI types
- Join code restored everywhere it was removed: sign-up, the join screen, the
  officers' club tools, and the backend checks. Docs, orientation page, slide
  deck, the sign-up clip and the walkthrough's opening line say so again.
- Names: every word starts with a capital however it was typed (sign-up,
  profile, the sign-up form's name questions, names added by hand, roster
  imports, rows read from the sheet, Google names). Stored that way too.
- MBTI: always in capitals; a proper type is pulled out of whatever surrounds
  it ("enfp-t" -> "ENFP"), in the page, the sheet read-back and every write.

Co-Authored-By: Claude Opus 5.5 <noreply@anthropic.com>
</commit_message>
<xml_diff>
--- a/slides/PBL-orientation.pptx
+++ b/slides/PBL-orientation.pptx
@@ -5800,7 +5800,7 @@
                 <a:ea typeface="Calibri" pitchFamily="34" charset="-122"/>
                 <a:cs typeface="Calibri" pitchFamily="34" charset="-120"/>
               </a:rPr>
-              <a:t>Name the divisions and ranks, create the sign-up form, share the site.</a:t>
+              <a:t>Name the divisions and ranks, create the sign-up form, hand out the join code.</a:t>
             </a:r>
             <a:endParaRPr lang="en-US" sz="1500" dirty="0"/>
           </a:p>
@@ -6846,7 +6846,7 @@
                 <a:ea typeface="Calibri" pitchFamily="34" charset="-122"/>
                 <a:cs typeface="Calibri" pitchFamily="34" charset="-120"/>
               </a:rPr>
-              <a:t>Sign in, pick De Anza PBL, send the sign-up form. Then find your Org under Teams and see where it stands.</a:t>
+              <a:t>Sign in, join with the code, send the sign-up form. Then find your Org under Teams and see where it stands.</a:t>
             </a:r>
             <a:endParaRPr lang="en-US" sz="1700" dirty="0"/>
           </a:p>
@@ -9095,7 +9095,7 @@
                 <a:ea typeface="Calibri" pitchFamily="34" charset="-122"/>
                 <a:cs typeface="Calibri" pitchFamily="34" charset="-120"/>
               </a:rPr>
-              <a:t>Pick it from the list, then send the sign-up form. The rest opens once it is in.</a:t>
+              <a:t>Pick it from the list and enter the join code your officers gave you.</a:t>
             </a:r>
             <a:endParaRPr lang="en-US" sz="1450" dirty="0"/>
           </a:p>

</xml_diff>